<commit_message>
doc: corrige slide 14 del PPT (segmento C0 -> C3, MDE 0.5pp) para consistencia con el informe y el resto del deck
</commit_message>
<xml_diff>
--- a/entrega_final/Presentación_Grupo_8_final.pptx
+++ b/entrega_final/Presentación_Grupo_8_final.pptx
@@ -10845,7 +10845,7 @@
                 <a:ea typeface="Calibri" pitchFamily="34" charset="-122"/>
                 <a:cs typeface="Calibri" pitchFamily="34" charset="-120"/>
               </a:rPr>
-              <a:t>C0: comprador de electrónica de alto valor</a:t>
+              <a:t>C3: electrónica gama media</a:t>
             </a:r>
             <a:r>
               <a:rPr lang="en-US" sz="1200">
@@ -10856,7 +10856,7 @@
                 <a:ea typeface="Calibri" pitchFamily="34" charset="-122"/>
                 <a:cs typeface="Calibri" pitchFamily="34" charset="-120"/>
               </a:rPr>
-              <a:t> — 42.6 % del tráfico, conv. 7.5 %. El 92.5 % de C0 no compra.</a:t>
+              <a:t> — 29.3 % del tráfico, conv. 8.4 %. El 91.6 % de C3 no compra.</a:t>
             </a:r>
             <a:endParaRPr lang="en-US" sz="1200"/>
           </a:p>
@@ -11799,7 +11799,7 @@
                 <a:ea typeface="Calibri" pitchFamily="34" charset="-122"/>
                 <a:cs typeface="Calibri" pitchFamily="34" charset="-120"/>
               </a:rPr>
-              <a:t>Segmento C0  ·  carrito activo en Electronics  ·  H₁ &gt; H₀ en 1.5 pp  ·  α = 0.05</a:t>
+              <a:t>Segmento C3  ·  carrito activo en Electronics  ·  H₁ &gt; H₀ en 0.5 pp  ·  α = 0.05</a:t>
             </a:r>
             <a:endParaRPr lang="en-US" sz="950"/>
           </a:p>

</xml_diff>